<commit_message>
refactor(core): adopt argumentwise architecture per ADR-002/005/006/013
Restructures domain models to process discrete legal arguments instead
of documents as a single unit. CatalogMatch removed; catalog_id lives
directly on ExtrahiertesArgument. wuerdigungs_status on
Abwaegungsstellungnahme is now a computed property aggregated from
per-argument statuses.

- Add ExtrahiertesArgument with full lifecycle fields (Triage + ResponseDrafting)
- Remove CatalogMatch entity (superseded by catalog_id on ExtrahiertesArgument)
- Abwaegungsstellungnahme: replace wuerdigungs_status field with @property,
  add argumente: list[ExtrahiertesArgument], remove rechtsgrundlagen and
  rechtliche_wuerdigung (moved to ExtrahiertesArgument)
- TriageResult: replace catalog_match/extracted_arguments/triage_confidence
  with extracted_arguments: list[ExtrahiertesArgument]
- Remove Literal import (was only used by deleted CatalogMatch)

ruff and mypy strict must pass before push.
</commit_message>
<xml_diff>
--- a/docs/Brainstorming.pptx
+++ b/docs/Brainstorming.pptx
@@ -8,7 +8,8 @@
     <p:sldId id="257" r:id="rId2"/>
     <p:sldId id="258" r:id="rId3"/>
     <p:sldId id="259" r:id="rId4"/>
-    <p:sldId id="256" r:id="rId5"/>
+    <p:sldId id="260" r:id="rId5"/>
+    <p:sldId id="256" r:id="rId6"/>
   </p:sldIdLst>
   <p:sldSz cx="12192000" cy="6858000"/>
   <p:notesSz cx="6858000" cy="9144000"/>
@@ -107,11 +108,128 @@
       </a:defRPr>
     </a:lvl9pPr>
   </p:defaultTextStyle>
+  <p:extLst>
+    <p:ext uri="{EFAFB233-063F-42B5-8137-9DF3F51BA10A}">
+      <p15:sldGuideLst xmlns:p15="http://schemas.microsoft.com/office/powerpoint/2012/main"/>
+    </p:ext>
+  </p:extLst>
 </p:presentation>
 </file>
 
 <file path=ppt/changesInfos/changesInfo1.xml><?xml version="1.0" encoding="utf-8"?>
 <pc:chgInfo xmlns:a="http://schemas.openxmlformats.org/drawingml/2006/main" xmlns:r="http://schemas.openxmlformats.org/officeDocument/2006/relationships" xmlns:ac="http://schemas.microsoft.com/office/drawing/2013/main/command" xmlns:pc="http://schemas.microsoft.com/office/powerpoint/2013/main/command">
+  <pc:docChgLst>
+    <pc:chgData name="Kevin Sokoll" userId="8ea57693378b11bd" providerId="LiveId" clId="{4284706E-6D6E-4354-889F-F56A7C2D958B}"/>
+    <pc:docChg chg="custSel addSld modSld">
+      <pc:chgData name="Kevin Sokoll" userId="8ea57693378b11bd" providerId="LiveId" clId="{4284706E-6D6E-4354-889F-F56A7C2D958B}" dt="2026-05-21T09:35:10.947" v="329" actId="1076"/>
+      <pc:docMkLst>
+        <pc:docMk/>
+      </pc:docMkLst>
+      <pc:sldChg chg="addSp delSp modSp add mod">
+        <pc:chgData name="Kevin Sokoll" userId="8ea57693378b11bd" providerId="LiveId" clId="{4284706E-6D6E-4354-889F-F56A7C2D958B}" dt="2026-05-21T09:35:10.947" v="329" actId="1076"/>
+        <pc:sldMkLst>
+          <pc:docMk/>
+          <pc:sldMk cId="2026535768" sldId="260"/>
+        </pc:sldMkLst>
+        <pc:spChg chg="add mod">
+          <ac:chgData name="Kevin Sokoll" userId="8ea57693378b11bd" providerId="LiveId" clId="{4284706E-6D6E-4354-889F-F56A7C2D958B}" dt="2026-05-21T09:33:56.618" v="161" actId="1076"/>
+          <ac:spMkLst>
+            <pc:docMk/>
+            <pc:sldMk cId="2026535768" sldId="260"/>
+            <ac:spMk id="5" creationId="{804F4466-0CF0-4B12-8646-EBBE16DFD439}"/>
+          </ac:spMkLst>
+        </pc:spChg>
+        <pc:spChg chg="add mod">
+          <ac:chgData name="Kevin Sokoll" userId="8ea57693378b11bd" providerId="LiveId" clId="{4284706E-6D6E-4354-889F-F56A7C2D958B}" dt="2026-05-21T09:33:56.618" v="161" actId="1076"/>
+          <ac:spMkLst>
+            <pc:docMk/>
+            <pc:sldMk cId="2026535768" sldId="260"/>
+            <ac:spMk id="6" creationId="{00593965-402A-422F-A612-E94DFA5F9055}"/>
+          </ac:spMkLst>
+        </pc:spChg>
+        <pc:spChg chg="add mod">
+          <ac:chgData name="Kevin Sokoll" userId="8ea57693378b11bd" providerId="LiveId" clId="{4284706E-6D6E-4354-889F-F56A7C2D958B}" dt="2026-05-21T09:33:56.618" v="161" actId="1076"/>
+          <ac:spMkLst>
+            <pc:docMk/>
+            <pc:sldMk cId="2026535768" sldId="260"/>
+            <ac:spMk id="7" creationId="{84460EB2-9AA6-4713-BEC3-82AD5C2C884A}"/>
+          </ac:spMkLst>
+        </pc:spChg>
+        <pc:spChg chg="add mod">
+          <ac:chgData name="Kevin Sokoll" userId="8ea57693378b11bd" providerId="LiveId" clId="{4284706E-6D6E-4354-889F-F56A7C2D958B}" dt="2026-05-21T09:35:08.747" v="328" actId="20577"/>
+          <ac:spMkLst>
+            <pc:docMk/>
+            <pc:sldMk cId="2026535768" sldId="260"/>
+            <ac:spMk id="8" creationId="{9E3CD23A-55E6-4D75-9303-F7B580F705DD}"/>
+          </ac:spMkLst>
+        </pc:spChg>
+        <pc:spChg chg="add mod">
+          <ac:chgData name="Kevin Sokoll" userId="8ea57693378b11bd" providerId="LiveId" clId="{4284706E-6D6E-4354-889F-F56A7C2D958B}" dt="2026-05-21T09:34:03.389" v="172" actId="5793"/>
+          <ac:spMkLst>
+            <pc:docMk/>
+            <pc:sldMk cId="2026535768" sldId="260"/>
+            <ac:spMk id="9" creationId="{22E73C9D-6C37-4E78-84CD-20C799D1D636}"/>
+          </ac:spMkLst>
+        </pc:spChg>
+        <pc:spChg chg="add mod">
+          <ac:chgData name="Kevin Sokoll" userId="8ea57693378b11bd" providerId="LiveId" clId="{4284706E-6D6E-4354-889F-F56A7C2D958B}" dt="2026-05-21T09:34:10.566" v="187" actId="20577"/>
+          <ac:spMkLst>
+            <pc:docMk/>
+            <pc:sldMk cId="2026535768" sldId="260"/>
+            <ac:spMk id="10" creationId="{E53ECEC2-63A4-4B84-8BD7-2BBE5BDFAA3D}"/>
+          </ac:spMkLst>
+        </pc:spChg>
+        <pc:spChg chg="add mod">
+          <ac:chgData name="Kevin Sokoll" userId="8ea57693378b11bd" providerId="LiveId" clId="{4284706E-6D6E-4354-889F-F56A7C2D958B}" dt="2026-05-21T09:34:20.891" v="192" actId="1076"/>
+          <ac:spMkLst>
+            <pc:docMk/>
+            <pc:sldMk cId="2026535768" sldId="260"/>
+            <ac:spMk id="11" creationId="{39313F9B-E524-494F-9DC0-739782C8A40D}"/>
+          </ac:spMkLst>
+        </pc:spChg>
+        <pc:spChg chg="add mod">
+          <ac:chgData name="Kevin Sokoll" userId="8ea57693378b11bd" providerId="LiveId" clId="{4284706E-6D6E-4354-889F-F56A7C2D958B}" dt="2026-05-21T09:34:34.221" v="220" actId="20577"/>
+          <ac:spMkLst>
+            <pc:docMk/>
+            <pc:sldMk cId="2026535768" sldId="260"/>
+            <ac:spMk id="12" creationId="{E0CBA448-76D1-4CBE-BA79-B17B85922676}"/>
+          </ac:spMkLst>
+        </pc:spChg>
+        <pc:spChg chg="add mod">
+          <ac:chgData name="Kevin Sokoll" userId="8ea57693378b11bd" providerId="LiveId" clId="{4284706E-6D6E-4354-889F-F56A7C2D958B}" dt="2026-05-21T09:34:39.731" v="222" actId="1076"/>
+          <ac:spMkLst>
+            <pc:docMk/>
+            <pc:sldMk cId="2026535768" sldId="260"/>
+            <ac:spMk id="13" creationId="{F51017C5-0215-4C2D-8E16-27A88EEF190E}"/>
+          </ac:spMkLst>
+        </pc:spChg>
+        <pc:spChg chg="add mod">
+          <ac:chgData name="Kevin Sokoll" userId="8ea57693378b11bd" providerId="LiveId" clId="{4284706E-6D6E-4354-889F-F56A7C2D958B}" dt="2026-05-21T09:35:10.947" v="329" actId="1076"/>
+          <ac:spMkLst>
+            <pc:docMk/>
+            <pc:sldMk cId="2026535768" sldId="260"/>
+            <ac:spMk id="14" creationId="{0A4882EB-04AD-44DB-8829-217643F0DCEC}"/>
+          </ac:spMkLst>
+        </pc:spChg>
+        <pc:spChg chg="mod">
+          <ac:chgData name="Kevin Sokoll" userId="8ea57693378b11bd" providerId="LiveId" clId="{4284706E-6D6E-4354-889F-F56A7C2D958B}" dt="2026-05-21T09:32:25.802" v="11" actId="20577"/>
+          <ac:spMkLst>
+            <pc:docMk/>
+            <pc:sldMk cId="2026535768" sldId="260"/>
+            <ac:spMk id="17" creationId="{1AE0CE8E-825C-41F0-ADA6-59B20328881B}"/>
+          </ac:spMkLst>
+        </pc:spChg>
+        <pc:spChg chg="del">
+          <ac:chgData name="Kevin Sokoll" userId="8ea57693378b11bd" providerId="LiveId" clId="{4284706E-6D6E-4354-889F-F56A7C2D958B}" dt="2026-05-21T09:32:28.402" v="12" actId="478"/>
+          <ac:spMkLst>
+            <pc:docMk/>
+            <pc:sldMk cId="2026535768" sldId="260"/>
+            <ac:spMk id="22" creationId="{12103089-8209-4065-88E3-42614E17C436}"/>
+          </ac:spMkLst>
+        </pc:spChg>
+      </pc:sldChg>
+    </pc:docChg>
+  </pc:docChgLst>
   <pc:docChgLst>
     <pc:chgData name="Kevin Sokoll" userId="8ea57693378b11bd" providerId="LiveId" clId="{D7AA2D50-F87D-494A-8FEB-9DA13612DFB6}"/>
     <pc:docChg chg="modSld">
@@ -286,7 +404,7 @@
           <a:p>
             <a:fld id="{75B82895-B6E1-499E-A2E3-C117FE5B0AB3}" type="datetimeFigureOut">
               <a:rPr lang="de-DE" smtClean="0"/>
-              <a:t>19.05.2026</a:t>
+              <a:t>21.05.2026</a:t>
             </a:fld>
             <a:endParaRPr lang="de-DE"/>
           </a:p>
@@ -484,7 +602,7 @@
           <a:p>
             <a:fld id="{75B82895-B6E1-499E-A2E3-C117FE5B0AB3}" type="datetimeFigureOut">
               <a:rPr lang="de-DE" smtClean="0"/>
-              <a:t>19.05.2026</a:t>
+              <a:t>21.05.2026</a:t>
             </a:fld>
             <a:endParaRPr lang="de-DE"/>
           </a:p>
@@ -692,7 +810,7 @@
           <a:p>
             <a:fld id="{75B82895-B6E1-499E-A2E3-C117FE5B0AB3}" type="datetimeFigureOut">
               <a:rPr lang="de-DE" smtClean="0"/>
-              <a:t>19.05.2026</a:t>
+              <a:t>21.05.2026</a:t>
             </a:fld>
             <a:endParaRPr lang="de-DE"/>
           </a:p>
@@ -890,7 +1008,7 @@
           <a:p>
             <a:fld id="{75B82895-B6E1-499E-A2E3-C117FE5B0AB3}" type="datetimeFigureOut">
               <a:rPr lang="de-DE" smtClean="0"/>
-              <a:t>19.05.2026</a:t>
+              <a:t>21.05.2026</a:t>
             </a:fld>
             <a:endParaRPr lang="de-DE"/>
           </a:p>
@@ -1165,7 +1283,7 @@
           <a:p>
             <a:fld id="{75B82895-B6E1-499E-A2E3-C117FE5B0AB3}" type="datetimeFigureOut">
               <a:rPr lang="de-DE" smtClean="0"/>
-              <a:t>19.05.2026</a:t>
+              <a:t>21.05.2026</a:t>
             </a:fld>
             <a:endParaRPr lang="de-DE"/>
           </a:p>
@@ -1430,7 +1548,7 @@
           <a:p>
             <a:fld id="{75B82895-B6E1-499E-A2E3-C117FE5B0AB3}" type="datetimeFigureOut">
               <a:rPr lang="de-DE" smtClean="0"/>
-              <a:t>19.05.2026</a:t>
+              <a:t>21.05.2026</a:t>
             </a:fld>
             <a:endParaRPr lang="de-DE"/>
           </a:p>
@@ -1842,7 +1960,7 @@
           <a:p>
             <a:fld id="{75B82895-B6E1-499E-A2E3-C117FE5B0AB3}" type="datetimeFigureOut">
               <a:rPr lang="de-DE" smtClean="0"/>
-              <a:t>19.05.2026</a:t>
+              <a:t>21.05.2026</a:t>
             </a:fld>
             <a:endParaRPr lang="de-DE"/>
           </a:p>
@@ -1983,7 +2101,7 @@
           <a:p>
             <a:fld id="{75B82895-B6E1-499E-A2E3-C117FE5B0AB3}" type="datetimeFigureOut">
               <a:rPr lang="de-DE" smtClean="0"/>
-              <a:t>19.05.2026</a:t>
+              <a:t>21.05.2026</a:t>
             </a:fld>
             <a:endParaRPr lang="de-DE"/>
           </a:p>
@@ -2096,7 +2214,7 @@
           <a:p>
             <a:fld id="{75B82895-B6E1-499E-A2E3-C117FE5B0AB3}" type="datetimeFigureOut">
               <a:rPr lang="de-DE" smtClean="0"/>
-              <a:t>19.05.2026</a:t>
+              <a:t>21.05.2026</a:t>
             </a:fld>
             <a:endParaRPr lang="de-DE"/>
           </a:p>
@@ -2407,7 +2525,7 @@
           <a:p>
             <a:fld id="{75B82895-B6E1-499E-A2E3-C117FE5B0AB3}" type="datetimeFigureOut">
               <a:rPr lang="de-DE" smtClean="0"/>
-              <a:t>19.05.2026</a:t>
+              <a:t>21.05.2026</a:t>
             </a:fld>
             <a:endParaRPr lang="de-DE"/>
           </a:p>
@@ -2695,7 +2813,7 @@
           <a:p>
             <a:fld id="{75B82895-B6E1-499E-A2E3-C117FE5B0AB3}" type="datetimeFigureOut">
               <a:rPr lang="de-DE" smtClean="0"/>
-              <a:t>19.05.2026</a:t>
+              <a:t>21.05.2026</a:t>
             </a:fld>
             <a:endParaRPr lang="de-DE"/>
           </a:p>
@@ -2936,7 +3054,7 @@
           <a:p>
             <a:fld id="{75B82895-B6E1-499E-A2E3-C117FE5B0AB3}" type="datetimeFigureOut">
               <a:rPr lang="de-DE" smtClean="0"/>
-              <a:t>19.05.2026</a:t>
+              <a:t>21.05.2026</a:t>
             </a:fld>
             <a:endParaRPr lang="de-DE"/>
           </a:p>
@@ -3924,12 +4042,12 @@
               <a:t> </a:t>
             </a:r>
             <a:r>
-              <a:rPr lang="de-DE"/>
-              <a:t>Retrievalt: </a:t>
+              <a:rPr lang="de-DE" dirty="0" err="1"/>
+              <a:t>Retrievalt</a:t>
             </a:r>
             <a:r>
               <a:rPr lang="de-DE" dirty="0"/>
-              <a:t>Erst Rechtsgebiet </a:t>
+              <a:t>: Erst Rechtsgebiet </a:t>
             </a:r>
             <a:r>
               <a:rPr lang="de-DE" dirty="0" err="1"/>
@@ -4106,6 +4224,584 @@
 </file>
 
 <file path=ppt/slides/slide4.xml><?xml version="1.0" encoding="utf-8"?>
+<p:sld xmlns:a="http://schemas.openxmlformats.org/drawingml/2006/main" xmlns:r="http://schemas.openxmlformats.org/officeDocument/2006/relationships" xmlns:p="http://schemas.openxmlformats.org/presentationml/2006/main">
+  <p:cSld>
+    <p:spTree>
+      <p:nvGrpSpPr>
+        <p:cNvPr id="1" name=""/>
+        <p:cNvGrpSpPr/>
+        <p:nvPr/>
+      </p:nvGrpSpPr>
+      <p:grpSpPr>
+        <a:xfrm>
+          <a:off x="0" y="0"/>
+          <a:ext cx="0" cy="0"/>
+          <a:chOff x="0" y="0"/>
+          <a:chExt cx="0" cy="0"/>
+        </a:xfrm>
+      </p:grpSpPr>
+      <p:sp>
+        <p:nvSpPr>
+          <p:cNvPr id="17" name="Textfeld 16">
+            <a:extLst>
+              <a:ext uri="{FF2B5EF4-FFF2-40B4-BE49-F238E27FC236}">
+                <a16:creationId xmlns:a16="http://schemas.microsoft.com/office/drawing/2014/main" id="{1AE0CE8E-825C-41F0-ADA6-59B20328881B}"/>
+              </a:ext>
+            </a:extLst>
+          </p:cNvPr>
+          <p:cNvSpPr txBox="1"/>
+          <p:nvPr/>
+        </p:nvSpPr>
+        <p:spPr>
+          <a:xfrm>
+            <a:off x="1408923" y="223118"/>
+            <a:ext cx="2136712" cy="584775"/>
+          </a:xfrm>
+          <a:prstGeom prst="rect">
+            <a:avLst/>
+          </a:prstGeom>
+          <a:noFill/>
+        </p:spPr>
+        <p:txBody>
+          <a:bodyPr wrap="square" rtlCol="0">
+            <a:spAutoFit/>
+          </a:bodyPr>
+          <a:lstStyle/>
+          <a:p>
+            <a:r>
+              <a:rPr lang="de-DE" sz="3200" dirty="0">
+                <a:solidFill>
+                  <a:schemeClr val="accent1"/>
+                </a:solidFill>
+              </a:rPr>
+              <a:t>Architektur</a:t>
+            </a:r>
+          </a:p>
+        </p:txBody>
+      </p:sp>
+      <p:pic>
+        <p:nvPicPr>
+          <p:cNvPr id="3" name="Grafik 2" descr="Puzzleteile mit einfarbiger Füllung">
+            <a:extLst>
+              <a:ext uri="{FF2B5EF4-FFF2-40B4-BE49-F238E27FC236}">
+                <a16:creationId xmlns:a16="http://schemas.microsoft.com/office/drawing/2014/main" id="{4797EDB7-AF23-4656-86BC-BA158B8FC1FF}"/>
+              </a:ext>
+            </a:extLst>
+          </p:cNvPr>
+          <p:cNvPicPr>
+            <a:picLocks noChangeAspect="1"/>
+          </p:cNvPicPr>
+          <p:nvPr/>
+        </p:nvPicPr>
+        <p:blipFill>
+          <a:blip r:embed="rId2">
+            <a:extLst>
+              <a:ext uri="{28A0092B-C50C-407E-A947-70E740481C1C}">
+                <a14:useLocalDpi xmlns:a14="http://schemas.microsoft.com/office/drawing/2010/main" val="0"/>
+              </a:ext>
+              <a:ext uri="{96DAC541-7B7A-43D3-8B79-37D633B846F1}">
+                <asvg:svgBlip xmlns:asvg="http://schemas.microsoft.com/office/drawing/2016/SVG/main" r:embed="rId3"/>
+              </a:ext>
+            </a:extLst>
+          </a:blip>
+          <a:stretch>
+            <a:fillRect/>
+          </a:stretch>
+        </p:blipFill>
+        <p:spPr>
+          <a:xfrm>
+            <a:off x="494523" y="-31862"/>
+            <a:ext cx="914400" cy="914400"/>
+          </a:xfrm>
+          <a:prstGeom prst="rect">
+            <a:avLst/>
+          </a:prstGeom>
+        </p:spPr>
+      </p:pic>
+      <p:sp>
+        <p:nvSpPr>
+          <p:cNvPr id="5" name="Flussdiagramm: Alternativer Prozess 4">
+            <a:extLst>
+              <a:ext uri="{FF2B5EF4-FFF2-40B4-BE49-F238E27FC236}">
+                <a16:creationId xmlns:a16="http://schemas.microsoft.com/office/drawing/2014/main" id="{804F4466-0CF0-4B12-8646-EBBE16DFD439}"/>
+              </a:ext>
+            </a:extLst>
+          </p:cNvPr>
+          <p:cNvSpPr/>
+          <p:nvPr/>
+        </p:nvSpPr>
+        <p:spPr>
+          <a:xfrm>
+            <a:off x="3956181" y="1034065"/>
+            <a:ext cx="1623526" cy="755780"/>
+          </a:xfrm>
+          <a:prstGeom prst="flowChartAlternateProcess">
+            <a:avLst/>
+          </a:prstGeom>
+        </p:spPr>
+        <p:style>
+          <a:lnRef idx="2">
+            <a:schemeClr val="accent1">
+              <a:shade val="50000"/>
+            </a:schemeClr>
+          </a:lnRef>
+          <a:fillRef idx="1">
+            <a:schemeClr val="accent1"/>
+          </a:fillRef>
+          <a:effectRef idx="0">
+            <a:schemeClr val="accent1"/>
+          </a:effectRef>
+          <a:fontRef idx="minor">
+            <a:schemeClr val="lt1"/>
+          </a:fontRef>
+        </p:style>
+        <p:txBody>
+          <a:bodyPr rtlCol="0" anchor="ctr"/>
+          <a:lstStyle/>
+          <a:p>
+            <a:pPr algn="ctr"/>
+            <a:r>
+              <a:rPr lang="de-DE" dirty="0"/>
+              <a:t>Rohdokument</a:t>
+            </a:r>
+          </a:p>
+        </p:txBody>
+      </p:sp>
+      <p:sp>
+        <p:nvSpPr>
+          <p:cNvPr id="6" name="Flussdiagramm: Alternativer Prozess 5">
+            <a:extLst>
+              <a:ext uri="{FF2B5EF4-FFF2-40B4-BE49-F238E27FC236}">
+                <a16:creationId xmlns:a16="http://schemas.microsoft.com/office/drawing/2014/main" id="{00593965-402A-422F-A612-E94DFA5F9055}"/>
+              </a:ext>
+            </a:extLst>
+          </p:cNvPr>
+          <p:cNvSpPr/>
+          <p:nvPr/>
+        </p:nvSpPr>
+        <p:spPr>
+          <a:xfrm>
+            <a:off x="3956181" y="1998228"/>
+            <a:ext cx="1623526" cy="755780"/>
+          </a:xfrm>
+          <a:prstGeom prst="flowChartAlternateProcess">
+            <a:avLst/>
+          </a:prstGeom>
+        </p:spPr>
+        <p:style>
+          <a:lnRef idx="2">
+            <a:schemeClr val="accent1">
+              <a:shade val="50000"/>
+            </a:schemeClr>
+          </a:lnRef>
+          <a:fillRef idx="1">
+            <a:schemeClr val="accent1"/>
+          </a:fillRef>
+          <a:effectRef idx="0">
+            <a:schemeClr val="accent1"/>
+          </a:effectRef>
+          <a:fontRef idx="minor">
+            <a:schemeClr val="lt1"/>
+          </a:fontRef>
+        </p:style>
+        <p:txBody>
+          <a:bodyPr rtlCol="0" anchor="ctr"/>
+          <a:lstStyle/>
+          <a:p>
+            <a:pPr algn="ctr"/>
+            <a:r>
+              <a:rPr lang="de-DE" dirty="0"/>
+              <a:t>PII-</a:t>
+            </a:r>
+            <a:r>
+              <a:rPr lang="de-DE" dirty="0" err="1"/>
+              <a:t>Masking</a:t>
+            </a:r>
+            <a:endParaRPr lang="de-DE" dirty="0"/>
+          </a:p>
+        </p:txBody>
+      </p:sp>
+      <p:sp>
+        <p:nvSpPr>
+          <p:cNvPr id="7" name="Flussdiagramm: Alternativer Prozess 6">
+            <a:extLst>
+              <a:ext uri="{FF2B5EF4-FFF2-40B4-BE49-F238E27FC236}">
+                <a16:creationId xmlns:a16="http://schemas.microsoft.com/office/drawing/2014/main" id="{84460EB2-9AA6-4713-BEC3-82AD5C2C884A}"/>
+              </a:ext>
+            </a:extLst>
+          </p:cNvPr>
+          <p:cNvSpPr/>
+          <p:nvPr/>
+        </p:nvSpPr>
+        <p:spPr>
+          <a:xfrm>
+            <a:off x="3956181" y="2962391"/>
+            <a:ext cx="1623526" cy="755780"/>
+          </a:xfrm>
+          <a:prstGeom prst="flowChartAlternateProcess">
+            <a:avLst/>
+          </a:prstGeom>
+        </p:spPr>
+        <p:style>
+          <a:lnRef idx="2">
+            <a:schemeClr val="accent1">
+              <a:shade val="50000"/>
+            </a:schemeClr>
+          </a:lnRef>
+          <a:fillRef idx="1">
+            <a:schemeClr val="accent1"/>
+          </a:fillRef>
+          <a:effectRef idx="0">
+            <a:schemeClr val="accent1"/>
+          </a:effectRef>
+          <a:fontRef idx="minor">
+            <a:schemeClr val="lt1"/>
+          </a:fontRef>
+        </p:style>
+        <p:txBody>
+          <a:bodyPr rtlCol="0" anchor="ctr"/>
+          <a:lstStyle/>
+          <a:p>
+            <a:pPr algn="ctr"/>
+            <a:r>
+              <a:rPr lang="de-DE" dirty="0"/>
+              <a:t>Triage</a:t>
+            </a:r>
+          </a:p>
+        </p:txBody>
+      </p:sp>
+      <p:sp>
+        <p:nvSpPr>
+          <p:cNvPr id="8" name="Textfeld 7">
+            <a:extLst>
+              <a:ext uri="{FF2B5EF4-FFF2-40B4-BE49-F238E27FC236}">
+                <a16:creationId xmlns:a16="http://schemas.microsoft.com/office/drawing/2014/main" id="{9E3CD23A-55E6-4D75-9303-F7B580F705DD}"/>
+              </a:ext>
+            </a:extLst>
+          </p:cNvPr>
+          <p:cNvSpPr txBox="1"/>
+          <p:nvPr/>
+        </p:nvSpPr>
+        <p:spPr>
+          <a:xfrm>
+            <a:off x="5579707" y="3003224"/>
+            <a:ext cx="6624737" cy="646331"/>
+          </a:xfrm>
+          <a:prstGeom prst="rect">
+            <a:avLst/>
+          </a:prstGeom>
+          <a:noFill/>
+        </p:spPr>
+        <p:txBody>
+          <a:bodyPr wrap="square" rtlCol="0">
+            <a:spAutoFit/>
+          </a:bodyPr>
+          <a:lstStyle/>
+          <a:p>
+            <a:pPr marL="285750" indent="-285750">
+              <a:buFontTx/>
+              <a:buChar char="-"/>
+            </a:pPr>
+            <a:r>
+              <a:rPr lang="de-DE" dirty="0"/>
+              <a:t>LLM: Extrahierte diskrete Rechtsargumente</a:t>
+            </a:r>
+          </a:p>
+          <a:p>
+            <a:pPr marL="285750" indent="-285750">
+              <a:buFontTx/>
+              <a:buChar char="-"/>
+            </a:pPr>
+            <a:r>
+              <a:rPr lang="de-DE" dirty="0"/>
+              <a:t>LLM: </a:t>
+            </a:r>
+            <a:r>
+              <a:rPr lang="de-DE" dirty="0" err="1"/>
+              <a:t>Preprocessed</a:t>
+            </a:r>
+            <a:r>
+              <a:rPr lang="de-DE" dirty="0"/>
+              <a:t> pro Argument</a:t>
+            </a:r>
+          </a:p>
+        </p:txBody>
+      </p:sp>
+      <p:sp>
+        <p:nvSpPr>
+          <p:cNvPr id="9" name="Textfeld 8">
+            <a:extLst>
+              <a:ext uri="{FF2B5EF4-FFF2-40B4-BE49-F238E27FC236}">
+                <a16:creationId xmlns:a16="http://schemas.microsoft.com/office/drawing/2014/main" id="{22E73C9D-6C37-4E78-84CD-20C799D1D636}"/>
+              </a:ext>
+            </a:extLst>
+          </p:cNvPr>
+          <p:cNvSpPr txBox="1"/>
+          <p:nvPr/>
+        </p:nvSpPr>
+        <p:spPr>
+          <a:xfrm>
+            <a:off x="5713447" y="346228"/>
+            <a:ext cx="6624737" cy="369332"/>
+          </a:xfrm>
+          <a:prstGeom prst="rect">
+            <a:avLst/>
+          </a:prstGeom>
+          <a:noFill/>
+        </p:spPr>
+        <p:txBody>
+          <a:bodyPr wrap="square" rtlCol="0">
+            <a:spAutoFit/>
+          </a:bodyPr>
+          <a:lstStyle/>
+          <a:p>
+            <a:r>
+              <a:rPr lang="de-DE" dirty="0"/>
+              <a:t>Ergebnis</a:t>
+            </a:r>
+          </a:p>
+        </p:txBody>
+      </p:sp>
+      <p:sp>
+        <p:nvSpPr>
+          <p:cNvPr id="10" name="Textfeld 9">
+            <a:extLst>
+              <a:ext uri="{FF2B5EF4-FFF2-40B4-BE49-F238E27FC236}">
+                <a16:creationId xmlns:a16="http://schemas.microsoft.com/office/drawing/2014/main" id="{E53ECEC2-63A4-4B84-8BD7-2BBE5BDFAA3D}"/>
+              </a:ext>
+            </a:extLst>
+          </p:cNvPr>
+          <p:cNvSpPr txBox="1"/>
+          <p:nvPr/>
+        </p:nvSpPr>
+        <p:spPr>
+          <a:xfrm>
+            <a:off x="3956181" y="330839"/>
+            <a:ext cx="6624737" cy="369332"/>
+          </a:xfrm>
+          <a:prstGeom prst="rect">
+            <a:avLst/>
+          </a:prstGeom>
+          <a:noFill/>
+        </p:spPr>
+        <p:txBody>
+          <a:bodyPr wrap="square" rtlCol="0">
+            <a:spAutoFit/>
+          </a:bodyPr>
+          <a:lstStyle/>
+          <a:p>
+            <a:r>
+              <a:rPr lang="de-DE" dirty="0"/>
+              <a:t>Schritt</a:t>
+            </a:r>
+          </a:p>
+        </p:txBody>
+      </p:sp>
+      <p:sp>
+        <p:nvSpPr>
+          <p:cNvPr id="11" name="Textfeld 10">
+            <a:extLst>
+              <a:ext uri="{FF2B5EF4-FFF2-40B4-BE49-F238E27FC236}">
+                <a16:creationId xmlns:a16="http://schemas.microsoft.com/office/drawing/2014/main" id="{39313F9B-E524-494F-9DC0-739782C8A40D}"/>
+              </a:ext>
+            </a:extLst>
+          </p:cNvPr>
+          <p:cNvSpPr txBox="1"/>
+          <p:nvPr/>
+        </p:nvSpPr>
+        <p:spPr>
+          <a:xfrm>
+            <a:off x="5713446" y="1227289"/>
+            <a:ext cx="6624737" cy="369332"/>
+          </a:xfrm>
+          <a:prstGeom prst="rect">
+            <a:avLst/>
+          </a:prstGeom>
+          <a:noFill/>
+        </p:spPr>
+        <p:txBody>
+          <a:bodyPr wrap="square" rtlCol="0">
+            <a:spAutoFit/>
+          </a:bodyPr>
+          <a:lstStyle/>
+          <a:p>
+            <a:pPr marL="285750" indent="-285750">
+              <a:buFontTx/>
+              <a:buChar char="-"/>
+            </a:pPr>
+            <a:r>
+              <a:rPr lang="de-DE" dirty="0"/>
+              <a:t>.</a:t>
+            </a:r>
+          </a:p>
+        </p:txBody>
+      </p:sp>
+      <p:sp>
+        <p:nvSpPr>
+          <p:cNvPr id="12" name="Textfeld 11">
+            <a:extLst>
+              <a:ext uri="{FF2B5EF4-FFF2-40B4-BE49-F238E27FC236}">
+                <a16:creationId xmlns:a16="http://schemas.microsoft.com/office/drawing/2014/main" id="{E0CBA448-76D1-4CBE-BA79-B17B85922676}"/>
+              </a:ext>
+            </a:extLst>
+          </p:cNvPr>
+          <p:cNvSpPr txBox="1"/>
+          <p:nvPr/>
+        </p:nvSpPr>
+        <p:spPr>
+          <a:xfrm>
+            <a:off x="5713446" y="2039061"/>
+            <a:ext cx="6624737" cy="646331"/>
+          </a:xfrm>
+          <a:prstGeom prst="rect">
+            <a:avLst/>
+          </a:prstGeom>
+          <a:noFill/>
+        </p:spPr>
+        <p:txBody>
+          <a:bodyPr wrap="square" rtlCol="0">
+            <a:spAutoFit/>
+          </a:bodyPr>
+          <a:lstStyle/>
+          <a:p>
+            <a:pPr marL="285750" indent="-285750">
+              <a:buFontTx/>
+              <a:buChar char="-"/>
+            </a:pPr>
+            <a:r>
+              <a:rPr lang="de-DE" dirty="0"/>
+              <a:t>Sauberer Text ohne PII</a:t>
+            </a:r>
+          </a:p>
+          <a:p>
+            <a:pPr marL="285750" indent="-285750">
+              <a:buFontTx/>
+              <a:buChar char="-"/>
+            </a:pPr>
+            <a:endParaRPr lang="de-DE" dirty="0"/>
+          </a:p>
+        </p:txBody>
+      </p:sp>
+      <p:sp>
+        <p:nvSpPr>
+          <p:cNvPr id="13" name="Flussdiagramm: Alternativer Prozess 12">
+            <a:extLst>
+              <a:ext uri="{FF2B5EF4-FFF2-40B4-BE49-F238E27FC236}">
+                <a16:creationId xmlns:a16="http://schemas.microsoft.com/office/drawing/2014/main" id="{F51017C5-0215-4C2D-8E16-27A88EEF190E}"/>
+              </a:ext>
+            </a:extLst>
+          </p:cNvPr>
+          <p:cNvSpPr/>
+          <p:nvPr/>
+        </p:nvSpPr>
+        <p:spPr>
+          <a:xfrm>
+            <a:off x="3956181" y="3866496"/>
+            <a:ext cx="1623526" cy="755780"/>
+          </a:xfrm>
+          <a:prstGeom prst="flowChartAlternateProcess">
+            <a:avLst/>
+          </a:prstGeom>
+        </p:spPr>
+        <p:style>
+          <a:lnRef idx="2">
+            <a:schemeClr val="accent1">
+              <a:shade val="50000"/>
+            </a:schemeClr>
+          </a:lnRef>
+          <a:fillRef idx="1">
+            <a:schemeClr val="accent1"/>
+          </a:fillRef>
+          <a:effectRef idx="0">
+            <a:schemeClr val="accent1"/>
+          </a:effectRef>
+          <a:fontRef idx="minor">
+            <a:schemeClr val="lt1"/>
+          </a:fontRef>
+        </p:style>
+        <p:txBody>
+          <a:bodyPr rtlCol="0" anchor="ctr"/>
+          <a:lstStyle/>
+          <a:p>
+            <a:pPr algn="ctr"/>
+            <a:r>
+              <a:rPr lang="de-DE" dirty="0"/>
+              <a:t>Triage</a:t>
+            </a:r>
+          </a:p>
+        </p:txBody>
+      </p:sp>
+      <p:sp>
+        <p:nvSpPr>
+          <p:cNvPr id="14" name="Textfeld 13">
+            <a:extLst>
+              <a:ext uri="{FF2B5EF4-FFF2-40B4-BE49-F238E27FC236}">
+                <a16:creationId xmlns:a16="http://schemas.microsoft.com/office/drawing/2014/main" id="{0A4882EB-04AD-44DB-8829-217643F0DCEC}"/>
+              </a:ext>
+            </a:extLst>
+          </p:cNvPr>
+          <p:cNvSpPr txBox="1"/>
+          <p:nvPr/>
+        </p:nvSpPr>
+        <p:spPr>
+          <a:xfrm>
+            <a:off x="5579707" y="3782721"/>
+            <a:ext cx="6624737" cy="923330"/>
+          </a:xfrm>
+          <a:prstGeom prst="rect">
+            <a:avLst/>
+          </a:prstGeom>
+          <a:noFill/>
+        </p:spPr>
+        <p:txBody>
+          <a:bodyPr wrap="square" rtlCol="0">
+            <a:spAutoFit/>
+          </a:bodyPr>
+          <a:lstStyle/>
+          <a:p>
+            <a:pPr marL="285750" indent="-285750">
+              <a:buFontTx/>
+              <a:buChar char="-"/>
+            </a:pPr>
+            <a:r>
+              <a:rPr lang="de-DE" dirty="0"/>
+              <a:t>Vektoren im jeweiligen Gesetz</a:t>
+            </a:r>
+          </a:p>
+          <a:p>
+            <a:pPr marL="285750" indent="-285750">
+              <a:buFontTx/>
+              <a:buChar char="-"/>
+            </a:pPr>
+            <a:r>
+              <a:rPr lang="de-DE" dirty="0"/>
+              <a:t>Pro Argument: </a:t>
+            </a:r>
+            <a:r>
+              <a:rPr lang="de-DE" dirty="0" err="1"/>
+              <a:t>Relevenate</a:t>
+            </a:r>
+            <a:r>
+              <a:rPr lang="de-DE" dirty="0"/>
+              <a:t> Paragraphen, Textvorschlag, Zusammenführung</a:t>
+            </a:r>
+          </a:p>
+        </p:txBody>
+      </p:sp>
+    </p:spTree>
+    <p:extLst>
+      <p:ext uri="{BB962C8B-B14F-4D97-AF65-F5344CB8AC3E}">
+        <p14:creationId xmlns:p14="http://schemas.microsoft.com/office/powerpoint/2010/main" val="2026535768"/>
+      </p:ext>
+    </p:extLst>
+  </p:cSld>
+  <p:clrMapOvr>
+    <a:masterClrMapping/>
+  </p:clrMapOvr>
+</p:sld>
+</file>
+
+<file path=ppt/slides/slide5.xml><?xml version="1.0" encoding="utf-8"?>
 <p:sld xmlns:a="http://schemas.openxmlformats.org/drawingml/2006/main" xmlns:r="http://schemas.openxmlformats.org/officeDocument/2006/relationships" xmlns:p="http://schemas.openxmlformats.org/presentationml/2006/main">
   <p:cSld>
     <p:spTree>

</xml_diff>

<commit_message>
feat(pipeline): implement coordinator and e2e smoke test
Walking skeleton complete. All four BCs wired end-to-end via Pipeline
coordinator. Smoke test confirms full pipeline traversal with stubbed
LLM and retriever.

- Add pipeline.py with Pipeline coordinator: sequential BC orchestration,
  per-step audit emit, PIPELINE_FEHLER on crash, stderr logging on
  audit failures
- Add tests/e2e/test_pipeline_smoke.py with 4 smoke tests: DRAFT result,
  audit event ordering, KEIN_TREFFER path, empty input rejection
- Add tests/conftest.py with shared FakeLLMClient, FakeRetriever and
  pipeline_and_audit fixture
- Remove einwendungs_typ from TriageResult (ADR-013: per-argument only)
- Fix all downstream references to use classify_einwendungs_typ()

42 tests pass. ruff and mypy strict clean.
</commit_message>
<xml_diff>
--- a/docs/Brainstorming.pptx
+++ b/docs/Brainstorming.pptx
@@ -121,10 +121,49 @@
   <pc:docChgLst>
     <pc:chgData name="Kevin Sokoll" userId="8ea57693378b11bd" providerId="LiveId" clId="{4284706E-6D6E-4354-889F-F56A7C2D958B}"/>
     <pc:docChg chg="custSel addSld modSld">
-      <pc:chgData name="Kevin Sokoll" userId="8ea57693378b11bd" providerId="LiveId" clId="{4284706E-6D6E-4354-889F-F56A7C2D958B}" dt="2026-05-21T09:35:10.947" v="329" actId="1076"/>
+      <pc:chgData name="Kevin Sokoll" userId="8ea57693378b11bd" providerId="LiveId" clId="{4284706E-6D6E-4354-889F-F56A7C2D958B}" dt="2026-05-23T08:59:52.705" v="337" actId="14100"/>
       <pc:docMkLst>
         <pc:docMk/>
       </pc:docMkLst>
+      <pc:sldChg chg="addSp delSp modSp mod">
+        <pc:chgData name="Kevin Sokoll" userId="8ea57693378b11bd" providerId="LiveId" clId="{4284706E-6D6E-4354-889F-F56A7C2D958B}" dt="2026-05-23T08:59:52.705" v="337" actId="14100"/>
+        <pc:sldMkLst>
+          <pc:docMk/>
+          <pc:sldMk cId="1931243368" sldId="256"/>
+        </pc:sldMkLst>
+        <pc:cxnChg chg="add">
+          <ac:chgData name="Kevin Sokoll" userId="8ea57693378b11bd" providerId="LiveId" clId="{4284706E-6D6E-4354-889F-F56A7C2D958B}" dt="2026-05-23T08:59:36.941" v="330" actId="11529"/>
+          <ac:cxnSpMkLst>
+            <pc:docMk/>
+            <pc:sldMk cId="1931243368" sldId="256"/>
+            <ac:cxnSpMk id="3" creationId="{B77D9B1C-4E94-4005-93A6-F606DEFE366A}"/>
+          </ac:cxnSpMkLst>
+        </pc:cxnChg>
+        <pc:cxnChg chg="add del mod">
+          <ac:chgData name="Kevin Sokoll" userId="8ea57693378b11bd" providerId="LiveId" clId="{4284706E-6D6E-4354-889F-F56A7C2D958B}" dt="2026-05-23T08:59:41.477" v="333" actId="478"/>
+          <ac:cxnSpMkLst>
+            <pc:docMk/>
+            <pc:sldMk cId="1931243368" sldId="256"/>
+            <ac:cxnSpMk id="22" creationId="{08F5CBAB-B3D7-4113-B5E8-03477343C760}"/>
+          </ac:cxnSpMkLst>
+        </pc:cxnChg>
+        <pc:cxnChg chg="add">
+          <ac:chgData name="Kevin Sokoll" userId="8ea57693378b11bd" providerId="LiveId" clId="{4284706E-6D6E-4354-889F-F56A7C2D958B}" dt="2026-05-23T08:59:47.119" v="334" actId="11529"/>
+          <ac:cxnSpMkLst>
+            <pc:docMk/>
+            <pc:sldMk cId="1931243368" sldId="256"/>
+            <ac:cxnSpMk id="24" creationId="{0137A27E-B34B-4AD6-A9CD-2A9778FA7D8F}"/>
+          </ac:cxnSpMkLst>
+        </pc:cxnChg>
+        <pc:cxnChg chg="add mod">
+          <ac:chgData name="Kevin Sokoll" userId="8ea57693378b11bd" providerId="LiveId" clId="{4284706E-6D6E-4354-889F-F56A7C2D958B}" dt="2026-05-23T08:59:52.705" v="337" actId="14100"/>
+          <ac:cxnSpMkLst>
+            <pc:docMk/>
+            <pc:sldMk cId="1931243368" sldId="256"/>
+            <ac:cxnSpMk id="25" creationId="{20B79F9E-8EE9-4D4D-B9A0-5522E4AB2A1E}"/>
+          </ac:cxnSpMkLst>
+        </pc:cxnChg>
+      </pc:sldChg>
       <pc:sldChg chg="addSp delSp modSp add mod">
         <pc:chgData name="Kevin Sokoll" userId="8ea57693378b11bd" providerId="LiveId" clId="{4284706E-6D6E-4354-889F-F56A7C2D958B}" dt="2026-05-21T09:35:10.947" v="329" actId="1076"/>
         <pc:sldMkLst>
@@ -404,7 +443,7 @@
           <a:p>
             <a:fld id="{75B82895-B6E1-499E-A2E3-C117FE5B0AB3}" type="datetimeFigureOut">
               <a:rPr lang="de-DE" smtClean="0"/>
-              <a:t>21.05.2026</a:t>
+              <a:t>23.05.2026</a:t>
             </a:fld>
             <a:endParaRPr lang="de-DE"/>
           </a:p>
@@ -602,7 +641,7 @@
           <a:p>
             <a:fld id="{75B82895-B6E1-499E-A2E3-C117FE5B0AB3}" type="datetimeFigureOut">
               <a:rPr lang="de-DE" smtClean="0"/>
-              <a:t>21.05.2026</a:t>
+              <a:t>23.05.2026</a:t>
             </a:fld>
             <a:endParaRPr lang="de-DE"/>
           </a:p>
@@ -810,7 +849,7 @@
           <a:p>
             <a:fld id="{75B82895-B6E1-499E-A2E3-C117FE5B0AB3}" type="datetimeFigureOut">
               <a:rPr lang="de-DE" smtClean="0"/>
-              <a:t>21.05.2026</a:t>
+              <a:t>23.05.2026</a:t>
             </a:fld>
             <a:endParaRPr lang="de-DE"/>
           </a:p>
@@ -1008,7 +1047,7 @@
           <a:p>
             <a:fld id="{75B82895-B6E1-499E-A2E3-C117FE5B0AB3}" type="datetimeFigureOut">
               <a:rPr lang="de-DE" smtClean="0"/>
-              <a:t>21.05.2026</a:t>
+              <a:t>23.05.2026</a:t>
             </a:fld>
             <a:endParaRPr lang="de-DE"/>
           </a:p>
@@ -1283,7 +1322,7 @@
           <a:p>
             <a:fld id="{75B82895-B6E1-499E-A2E3-C117FE5B0AB3}" type="datetimeFigureOut">
               <a:rPr lang="de-DE" smtClean="0"/>
-              <a:t>21.05.2026</a:t>
+              <a:t>23.05.2026</a:t>
             </a:fld>
             <a:endParaRPr lang="de-DE"/>
           </a:p>
@@ -1548,7 +1587,7 @@
           <a:p>
             <a:fld id="{75B82895-B6E1-499E-A2E3-C117FE5B0AB3}" type="datetimeFigureOut">
               <a:rPr lang="de-DE" smtClean="0"/>
-              <a:t>21.05.2026</a:t>
+              <a:t>23.05.2026</a:t>
             </a:fld>
             <a:endParaRPr lang="de-DE"/>
           </a:p>
@@ -1960,7 +1999,7 @@
           <a:p>
             <a:fld id="{75B82895-B6E1-499E-A2E3-C117FE5B0AB3}" type="datetimeFigureOut">
               <a:rPr lang="de-DE" smtClean="0"/>
-              <a:t>21.05.2026</a:t>
+              <a:t>23.05.2026</a:t>
             </a:fld>
             <a:endParaRPr lang="de-DE"/>
           </a:p>
@@ -2101,7 +2140,7 @@
           <a:p>
             <a:fld id="{75B82895-B6E1-499E-A2E3-C117FE5B0AB3}" type="datetimeFigureOut">
               <a:rPr lang="de-DE" smtClean="0"/>
-              <a:t>21.05.2026</a:t>
+              <a:t>23.05.2026</a:t>
             </a:fld>
             <a:endParaRPr lang="de-DE"/>
           </a:p>
@@ -2214,7 +2253,7 @@
           <a:p>
             <a:fld id="{75B82895-B6E1-499E-A2E3-C117FE5B0AB3}" type="datetimeFigureOut">
               <a:rPr lang="de-DE" smtClean="0"/>
-              <a:t>21.05.2026</a:t>
+              <a:t>23.05.2026</a:t>
             </a:fld>
             <a:endParaRPr lang="de-DE"/>
           </a:p>
@@ -2525,7 +2564,7 @@
           <a:p>
             <a:fld id="{75B82895-B6E1-499E-A2E3-C117FE5B0AB3}" type="datetimeFigureOut">
               <a:rPr lang="de-DE" smtClean="0"/>
-              <a:t>21.05.2026</a:t>
+              <a:t>23.05.2026</a:t>
             </a:fld>
             <a:endParaRPr lang="de-DE"/>
           </a:p>
@@ -2813,7 +2852,7 @@
           <a:p>
             <a:fld id="{75B82895-B6E1-499E-A2E3-C117FE5B0AB3}" type="datetimeFigureOut">
               <a:rPr lang="de-DE" smtClean="0"/>
-              <a:t>21.05.2026</a:t>
+              <a:t>23.05.2026</a:t>
             </a:fld>
             <a:endParaRPr lang="de-DE"/>
           </a:p>
@@ -3054,7 +3093,7 @@
           <a:p>
             <a:fld id="{75B82895-B6E1-499E-A2E3-C117FE5B0AB3}" type="datetimeFigureOut">
               <a:rPr lang="de-DE" smtClean="0"/>
-              <a:t>21.05.2026</a:t>
+              <a:t>23.05.2026</a:t>
             </a:fld>
             <a:endParaRPr lang="de-DE"/>
           </a:p>
@@ -5605,6 +5644,133 @@
           </a:p>
         </p:txBody>
       </p:sp>
+      <p:cxnSp>
+        <p:nvCxnSpPr>
+          <p:cNvPr id="3" name="Gerade Verbindung mit Pfeil 2">
+            <a:extLst>
+              <a:ext uri="{FF2B5EF4-FFF2-40B4-BE49-F238E27FC236}">
+                <a16:creationId xmlns:a16="http://schemas.microsoft.com/office/drawing/2014/main" id="{B77D9B1C-4E94-4005-93A6-F606DEFE366A}"/>
+              </a:ext>
+            </a:extLst>
+          </p:cNvPr>
+          <p:cNvCxnSpPr>
+            <a:stCxn id="9" idx="3"/>
+            <a:endCxn id="10" idx="1"/>
+          </p:cNvCxnSpPr>
+          <p:nvPr/>
+        </p:nvCxnSpPr>
+        <p:spPr>
+          <a:xfrm>
+            <a:off x="4130350" y="2667000"/>
+            <a:ext cx="304800" cy="0"/>
+          </a:xfrm>
+          <a:prstGeom prst="straightConnector1">
+            <a:avLst/>
+          </a:prstGeom>
+          <a:ln>
+            <a:tailEnd type="triangle"/>
+          </a:ln>
+        </p:spPr>
+        <p:style>
+          <a:lnRef idx="1">
+            <a:schemeClr val="accent1"/>
+          </a:lnRef>
+          <a:fillRef idx="0">
+            <a:schemeClr val="accent1"/>
+          </a:fillRef>
+          <a:effectRef idx="0">
+            <a:schemeClr val="accent1"/>
+          </a:effectRef>
+          <a:fontRef idx="minor">
+            <a:schemeClr val="tx1"/>
+          </a:fontRef>
+        </p:style>
+      </p:cxnSp>
+      <p:cxnSp>
+        <p:nvCxnSpPr>
+          <p:cNvPr id="24" name="Verbinder: gewinkelt 23">
+            <a:extLst>
+              <a:ext uri="{FF2B5EF4-FFF2-40B4-BE49-F238E27FC236}">
+                <a16:creationId xmlns:a16="http://schemas.microsoft.com/office/drawing/2014/main" id="{0137A27E-B34B-4AD6-A9CD-2A9778FA7D8F}"/>
+              </a:ext>
+            </a:extLst>
+          </p:cNvPr>
+          <p:cNvCxnSpPr>
+            <a:stCxn id="10" idx="2"/>
+            <a:endCxn id="13" idx="0"/>
+          </p:cNvCxnSpPr>
+          <p:nvPr/>
+        </p:nvCxnSpPr>
+        <p:spPr>
+          <a:xfrm rot="5400000">
+            <a:off x="2869163" y="1565988"/>
+            <a:ext cx="898849" cy="3856652"/>
+          </a:xfrm>
+          <a:prstGeom prst="bentConnector3">
+            <a:avLst/>
+          </a:prstGeom>
+          <a:ln>
+            <a:tailEnd type="triangle"/>
+          </a:ln>
+        </p:spPr>
+        <p:style>
+          <a:lnRef idx="1">
+            <a:schemeClr val="accent1"/>
+          </a:lnRef>
+          <a:fillRef idx="0">
+            <a:schemeClr val="accent1"/>
+          </a:fillRef>
+          <a:effectRef idx="0">
+            <a:schemeClr val="accent1"/>
+          </a:effectRef>
+          <a:fontRef idx="minor">
+            <a:schemeClr val="tx1"/>
+          </a:fontRef>
+        </p:style>
+      </p:cxnSp>
+      <p:cxnSp>
+        <p:nvCxnSpPr>
+          <p:cNvPr id="25" name="Gerade Verbindung mit Pfeil 24">
+            <a:extLst>
+              <a:ext uri="{FF2B5EF4-FFF2-40B4-BE49-F238E27FC236}">
+                <a16:creationId xmlns:a16="http://schemas.microsoft.com/office/drawing/2014/main" id="{20B79F9E-8EE9-4D4D-B9A0-5522E4AB2A1E}"/>
+              </a:ext>
+            </a:extLst>
+          </p:cNvPr>
+          <p:cNvCxnSpPr>
+            <a:cxnSpLocks/>
+            <a:stCxn id="8" idx="3"/>
+            <a:endCxn id="9" idx="1"/>
+          </p:cNvCxnSpPr>
+          <p:nvPr/>
+        </p:nvCxnSpPr>
+        <p:spPr>
+          <a:xfrm>
+            <a:off x="2202024" y="2667000"/>
+            <a:ext cx="304800" cy="0"/>
+          </a:xfrm>
+          <a:prstGeom prst="straightConnector1">
+            <a:avLst/>
+          </a:prstGeom>
+          <a:ln>
+            <a:tailEnd type="triangle"/>
+          </a:ln>
+        </p:spPr>
+        <p:style>
+          <a:lnRef idx="1">
+            <a:schemeClr val="accent1"/>
+          </a:lnRef>
+          <a:fillRef idx="0">
+            <a:schemeClr val="accent1"/>
+          </a:fillRef>
+          <a:effectRef idx="0">
+            <a:schemeClr val="accent1"/>
+          </a:effectRef>
+          <a:fontRef idx="minor">
+            <a:schemeClr val="tx1"/>
+          </a:fontRef>
+        </p:style>
+      </p:cxnSp>
     </p:spTree>
     <p:extLst>
       <p:ext uri="{BB962C8B-B14F-4D97-AF65-F5344CB8AC3E}">

</xml_diff>